<commit_message>
Hoàn thiện bài tập báo cáo
</commit_message>
<xml_diff>
--- a/SLIDE_MUC_7_FIREBASE_SETUP_NHOM16.pptx
+++ b/SLIDE_MUC_7_FIREBASE_SETUP_NHOM16.pptx
@@ -2312,6 +2312,23 @@
             </a:r>
             <a:endParaRPr lang="en-US" sz="2000" dirty="0"/>
           </a:p>
+          <a:p>
+            <a:pPr indent="0" marL="0">
+              <a:spcAft>
+                <a:spcPts val="400"/>
+              </a:spcAft>
+              <a:buNone/>
+            </a:pPr>
+            <a:r>
+              <a:rPr lang="en-US" sz="1800" dirty="0">
+                <a:solidFill>
+                  <a:schemeClr val="accent5"/>
+                </a:solidFill>
+              </a:rPr>
+              <a:t>Giảng viên hướng dẫn: ThS. Đỗ Oanh Cường</a:t>
+            </a:r>
+            <a:endParaRPr lang="en-US" sz="2000" dirty="0"/>
+          </a:p>
         </p:txBody>
       </p:sp>
       <p:sp>
@@ -2494,7 +2511,7 @@
                   <a:schemeClr val="accent5"/>
                 </a:solidFill>
               </a:rPr>
-              <a:t>Thành viên  ·  MSSV 2351170605</a:t>
+              <a:t>Thành viên  ·  MSSV 2351170629</a:t>
             </a:r>
             <a:endParaRPr lang="en-US" sz="1600" dirty="0"/>
           </a:p>
@@ -2544,7 +2561,7 @@
                   <a:schemeClr val="accent5"/>
                 </a:solidFill>
               </a:rPr>
-              <a:t>Thành viên  ·  MSSV 2351170570</a:t>
+              <a:t>Thành viên  ·  MSSV 2251172394</a:t>
             </a:r>
             <a:endParaRPr lang="en-US" sz="1600" dirty="0"/>
           </a:p>

</xml_diff>